<commit_message>
Drop Tableau mentions from the in-depth deck
Co-Authored-By: Claude Fable 5.1 <noreply@anthropic.com>
Claude-Session: https://claude.ai/code/session_016ymAbFop2FTD6QPnsmgJsn
</commit_message>
<xml_diff>
--- a/weibee-steel/docs/Weibee_Bid_Intelligence_In_Depth.pptx
+++ b/weibee-steel/docs/Weibee_Bid_Intelligence_In_Depth.pptx
@@ -139,13 +139,13 @@
   <p:extLst>
     <p:ext uri="{521415D9-36F7-43E2-AB2F-B90AF26B5E84}">
       <p14:sectionLst xmlns:p14="http://schemas.microsoft.com/office/powerpoint/2010/main">
-        <p14:section name="Opening" id="{7dc8a784-d4f2-ec31-fc75-bc70135e6995}">
+        <p14:section name="Opening" id="{c49118fe-13a7-5a37-481f-1e998958eb2e}">
           <p14:sldIdLst>
             <p14:sldId id="256"/>
             <p14:sldId id="257"/>
           </p14:sldIdLst>
         </p14:section>
-        <p14:section name="1. Problem and approach" id="{f28745ba-3998-1fba-5f98-de23ec5c8d9e}">
+        <p14:section name="1. Problem and approach" id="{2f43ebe3-4bb6-a448-df15-a8a178719120}">
           <p14:sldIdLst>
             <p14:sldId id="258"/>
             <p14:sldId id="259"/>
@@ -153,7 +153,7 @@
             <p14:sldId id="261"/>
           </p14:sldIdLst>
         </p14:section>
-        <p14:section name="2. What the data says" id="{7273c07e-2330-f384-14af-f6549d2bd392}">
+        <p14:section name="2. What the data says" id="{e79ad093-89b3-fee0-7503-afabb4efd005}">
           <p14:sldIdLst>
             <p14:sldId id="262"/>
             <p14:sldId id="263"/>
@@ -168,7 +168,7 @@
             <p14:sldId id="272"/>
           </p14:sldIdLst>
         </p14:section>
-        <p14:section name="3. The decision tool" id="{527bd309-8768-784d-2532-d88858568e06}">
+        <p14:section name="3. The decision tool" id="{c6dd041a-6755-c241-a3f8-e607677deed8}">
           <p14:sldIdLst>
             <p14:sldId id="273"/>
             <p14:sldId id="274"/>
@@ -178,14 +178,14 @@
             <p14:sldId id="278"/>
           </p14:sldIdLst>
         </p14:section>
-        <p14:section name="4. Trust" id="{57854430-87b5-3ca1-85e7-03b2417e3caf}">
+        <p14:section name="4. Trust" id="{53a92b77-3cdf-24f2-a677-4f9f1955fb92}">
           <p14:sldIdLst>
             <p14:sldId id="279"/>
             <p14:sldId id="280"/>
             <p14:sldId id="281"/>
           </p14:sldIdLst>
         </p14:section>
-        <p14:section name="5. Making it real" id="{9f5062ed-2659-2e0a-302d-a9da2c187a94}">
+        <p14:section name="5. Making it real" id="{7418c48e-601a-4a94-ef1f-01c60fe89b90}">
           <p14:sldIdLst>
             <p14:sldId id="282"/>
             <p14:sldId id="283"/>
@@ -37690,7 +37690,7 @@
                           <a:ea typeface="+mn-lt" pitchFamily="34" charset="-122"/>
                           <a:cs typeface="+mn-lt" pitchFamily="34" charset="-120"/>
                         </a:rPr>
-                        <a:t>One HTML page, a PDF, a Tableau data layer</a:t>
+                        <a:t>One HTML page and a PDF</a:t>
                       </a:r>
                       <a:endParaRPr lang="en-US" sz="950" dirty="0">
                         <a:latin typeface="+mn-lt" charset="0"/>
@@ -42148,7 +42148,7 @@
                   <a:schemeClr val="accent6"/>
                 </a:solidFill>
               </a:rPr>
-              <a:t>Report, Tableau data, technical design and code are in the repository. The method runs unchanged on real history.</a:t>
+              <a:t>Report, technical design and code come with this deck. The method runs unchanged on real history.</a:t>
             </a:r>
             <a:endParaRPr lang="en-US" sz="1700" dirty="0"/>
           </a:p>

</xml_diff>